<commit_message>
changed logo, moved exercises, updated overview for lecture on virtualization
</commit_message>
<xml_diff>
--- a/slides/virtualization.pptx
+++ b/slides/virtualization.pptx
@@ -9762,7 +9762,7 @@
           <a:p>
             <a:fld id="{F5CA1724-FE87-D744-AEFA-DF7E2B83349C}" type="datetimeFigureOut">
               <a:rPr lang="en-SE" smtClean="0"/>
-              <a:t>7/12/26</a:t>
+              <a:t>7/14/26</a:t>
             </a:fld>
             <a:endParaRPr lang="en-SE"/>
           </a:p>
@@ -17075,114 +17075,104 @@
           </a:p>
         </p:txBody>
       </p:sp>
-      <p:pic>
-        <p:nvPicPr>
-          <p:cNvPr id="5123" name="Picture 6" descr="http://upload.wikimedia.org/wikipedia/en/5/5c/Chalmers_logo.png"/>
-          <p:cNvPicPr>
-            <a:picLocks noChangeAspect="1" noChangeArrowheads="1"/>
-          </p:cNvPicPr>
-          <p:nvPr/>
-        </p:nvPicPr>
-        <p:blipFill>
-          <a:blip r:embed="rId3" cstate="screen">
+      <p:grpSp>
+        <p:nvGrpSpPr>
+          <p:cNvPr id="2" name="Group 1">
             <a:extLst>
-              <a:ext uri="{28A0092B-C50C-407E-A947-70E740481C1C}">
-                <a14:useLocalDpi xmlns:a14="http://schemas.microsoft.com/office/drawing/2010/main"/>
+              <a:ext uri="{FF2B5EF4-FFF2-40B4-BE49-F238E27FC236}">
+                <a16:creationId xmlns:a16="http://schemas.microsoft.com/office/drawing/2014/main" id="{4C4701C0-5203-16A1-0C12-B3CC7D54FD55}"/>
               </a:ext>
             </a:extLst>
-          </a:blip>
-          <a:srcRect/>
-          <a:stretch>
-            <a:fillRect/>
-          </a:stretch>
-        </p:blipFill>
-        <p:spPr bwMode="auto">
+          </p:cNvPr>
+          <p:cNvGrpSpPr/>
+          <p:nvPr/>
+        </p:nvGrpSpPr>
+        <p:grpSpPr>
           <a:xfrm>
-            <a:off x="4322234" y="4392085"/>
-            <a:ext cx="1672167" cy="1553633"/>
+            <a:off x="2495989" y="4734746"/>
+            <a:ext cx="7104771" cy="1547400"/>
+            <a:chOff x="777241" y="4793437"/>
+            <a:chExt cx="7104771" cy="1547400"/>
           </a:xfrm>
-          <a:prstGeom prst="rect">
-            <a:avLst/>
-          </a:prstGeom>
-          <a:noFill/>
-          <a:ln>
+        </p:grpSpPr>
+        <p:pic>
+          <p:nvPicPr>
+            <p:cNvPr id="3" name="Picture 2">
+              <a:extLst>
+                <a:ext uri="{FF2B5EF4-FFF2-40B4-BE49-F238E27FC236}">
+                  <a16:creationId xmlns:a16="http://schemas.microsoft.com/office/drawing/2014/main" id="{3BBE0694-08F4-B895-E9AF-2AFC62B4F9EC}"/>
+                </a:ext>
+              </a:extLst>
+            </p:cNvPr>
+            <p:cNvPicPr>
+              <a:picLocks noChangeAspect="1" noChangeArrowheads="1"/>
+            </p:cNvPicPr>
+            <p:nvPr/>
+          </p:nvPicPr>
+          <p:blipFill>
+            <a:blip r:embed="rId3">
+              <a:extLst>
+                <a:ext uri="{28A0092B-C50C-407E-A947-70E740481C1C}">
+                  <a14:useLocalDpi xmlns:a14="http://schemas.microsoft.com/office/drawing/2010/main" val="0"/>
+                </a:ext>
+              </a:extLst>
+            </a:blip>
+            <a:srcRect/>
+            <a:stretch>
+              <a:fillRect/>
+            </a:stretch>
+          </p:blipFill>
+          <p:spPr bwMode="auto">
+            <a:xfrm>
+              <a:off x="5803022" y="4793437"/>
+              <a:ext cx="2078990" cy="1547400"/>
+            </a:xfrm>
+            <a:prstGeom prst="rect">
+              <a:avLst/>
+            </a:prstGeom>
             <a:noFill/>
-          </a:ln>
-          <a:extLst>
-            <a:ext uri="{909E8E84-426E-40DD-AFC4-6F175D3DCCD1}">
-              <a14:hiddenFill xmlns:a14="http://schemas.microsoft.com/office/drawing/2010/main">
-                <a:solidFill>
-                  <a:srgbClr val="FFFFFF"/>
-                </a:solidFill>
-              </a14:hiddenFill>
-            </a:ext>
-            <a:ext uri="{91240B29-F687-4F45-9708-019B960494DF}">
-              <a14:hiddenLine xmlns:a14="http://schemas.microsoft.com/office/drawing/2010/main" w="9525">
-                <a:solidFill>
-                  <a:srgbClr val="000000"/>
-                </a:solidFill>
-                <a:miter lim="800000"/>
-                <a:headEnd/>
-                <a:tailEnd/>
-              </a14:hiddenLine>
-            </a:ext>
-          </a:extLst>
-        </p:spPr>
-      </p:pic>
-      <p:pic>
-        <p:nvPicPr>
-          <p:cNvPr id="5124" name="Picture 8" descr="http://sgroup.be/sites/default/files/LOGUeng_cen2r.gif"/>
-          <p:cNvPicPr>
-            <a:picLocks noChangeAspect="1" noChangeArrowheads="1"/>
-          </p:cNvPicPr>
-          <p:nvPr/>
-        </p:nvPicPr>
-        <p:blipFill>
-          <a:blip r:embed="rId4" cstate="screen">
             <a:extLst>
-              <a:ext uri="{28A0092B-C50C-407E-A947-70E740481C1C}">
-                <a14:useLocalDpi xmlns:a14="http://schemas.microsoft.com/office/drawing/2010/main"/>
+              <a:ext uri="{909E8E84-426E-40DD-AFC4-6F175D3DCCD1}">
+                <a14:hiddenFill xmlns:a14="http://schemas.microsoft.com/office/drawing/2010/main">
+                  <a:solidFill>
+                    <a:srgbClr val="FFFFFF"/>
+                  </a:solidFill>
+                </a14:hiddenFill>
               </a:ext>
             </a:extLst>
-          </a:blip>
-          <a:srcRect/>
-          <a:stretch>
-            <a:fillRect/>
-          </a:stretch>
-        </p:blipFill>
-        <p:spPr bwMode="auto">
-          <a:xfrm>
-            <a:off x="6164792" y="4480985"/>
-            <a:ext cx="1847850" cy="1375833"/>
-          </a:xfrm>
-          <a:prstGeom prst="rect">
-            <a:avLst/>
-          </a:prstGeom>
-          <a:noFill/>
-          <a:ln>
-            <a:noFill/>
-          </a:ln>
-          <a:extLst>
-            <a:ext uri="{909E8E84-426E-40DD-AFC4-6F175D3DCCD1}">
-              <a14:hiddenFill xmlns:a14="http://schemas.microsoft.com/office/drawing/2010/main">
-                <a:solidFill>
-                  <a:srgbClr val="FFFFFF"/>
-                </a:solidFill>
-              </a14:hiddenFill>
-            </a:ext>
-            <a:ext uri="{91240B29-F687-4F45-9708-019B960494DF}">
-              <a14:hiddenLine xmlns:a14="http://schemas.microsoft.com/office/drawing/2010/main" w="9525">
-                <a:solidFill>
-                  <a:srgbClr val="000000"/>
-                </a:solidFill>
-                <a:miter lim="800000"/>
-                <a:headEnd/>
-                <a:tailEnd/>
-              </a14:hiddenLine>
-            </a:ext>
-          </a:extLst>
-        </p:spPr>
-      </p:pic>
+          </p:spPr>
+        </p:pic>
+        <p:pic>
+          <p:nvPicPr>
+            <p:cNvPr id="5" name="Picture 4">
+              <a:extLst>
+                <a:ext uri="{FF2B5EF4-FFF2-40B4-BE49-F238E27FC236}">
+                  <a16:creationId xmlns:a16="http://schemas.microsoft.com/office/drawing/2014/main" id="{9ABB56D5-8A33-D4C0-B0A1-119BF1987104}"/>
+                </a:ext>
+              </a:extLst>
+            </p:cNvPr>
+            <p:cNvPicPr>
+              <a:picLocks noChangeAspect="1"/>
+            </p:cNvPicPr>
+            <p:nvPr/>
+          </p:nvPicPr>
+          <p:blipFill>
+            <a:blip r:embed="rId4"/>
+            <a:stretch>
+              <a:fillRect/>
+            </a:stretch>
+          </p:blipFill>
+          <p:spPr>
+            <a:xfrm>
+              <a:off x="777241" y="4973870"/>
+              <a:ext cx="4724632" cy="1186535"/>
+            </a:xfrm>
+            <a:prstGeom prst="rect">
+              <a:avLst/>
+            </a:prstGeom>
+          </p:spPr>
+        </p:pic>
+      </p:grpSp>
     </p:spTree>
     <p:extLst>
       <p:ext uri="{BB962C8B-B14F-4D97-AF65-F5344CB8AC3E}">
@@ -20239,32 +20229,7 @@
             </a:pPr>
             <a:r>
               <a:rPr lang="en-US" altLang="en-US" sz="2400" dirty="0"/>
-              <a:t>4</a:t>
-            </a:r>
-            <a:r>
-              <a:rPr lang="en-US" altLang="en-US" sz="2400" baseline="30000" dirty="0"/>
-              <a:t>th</a:t>
-            </a:r>
-            <a:r>
-              <a:rPr lang="en-US" altLang="en-US" sz="2400" dirty="0"/>
-              <a:t> Edition: Chapter 7, 7.1-7.7 and 7.9-7.11 (included)</a:t>
-            </a:r>
-            <a:endParaRPr lang="en-US" altLang="en-US" sz="2000" dirty="0"/>
-          </a:p>
-          <a:p>
-            <a:pPr marL="228600" lvl="1">
-              <a:spcBef>
-                <a:spcPts val="1000"/>
-              </a:spcBef>
-              <a:defRPr/>
-            </a:pPr>
-            <a:r>
-              <a:rPr lang="en-US" altLang="en-US" dirty="0"/>
-              <a:t>5th</a:t>
-            </a:r>
-            <a:r>
-              <a:rPr lang="en-US" altLang="en-US" sz="2400" dirty="0"/>
-              <a:t> Edition: Chapter 7, 7.1-7.</a:t>
+              <a:t>Chapter 7, 7.1-7.</a:t>
             </a:r>
             <a:r>
               <a:rPr lang="en-US" altLang="en-US" dirty="0"/>
@@ -20274,43 +20239,6 @@
               <a:rPr lang="en-US" altLang="en-US" sz="2400" dirty="0"/>
               <a:t> (included)</a:t>
             </a:r>
-          </a:p>
-          <a:p>
-            <a:pPr marL="685800" lvl="2">
-              <a:spcBef>
-                <a:spcPts val="1000"/>
-              </a:spcBef>
-              <a:defRPr/>
-            </a:pPr>
-            <a:r>
-              <a:rPr lang="en-US" altLang="en-US" dirty="0"/>
-              <a:t>Note: part on Containers only in 5</a:t>
-            </a:r>
-            <a:r>
-              <a:rPr lang="en-US" altLang="en-US" baseline="30000" dirty="0"/>
-              <a:t>th</a:t>
-            </a:r>
-            <a:r>
-              <a:rPr lang="en-US" altLang="en-US" dirty="0"/>
-              <a:t> edition. Slides are enough if you do not have the 5</a:t>
-            </a:r>
-            <a:r>
-              <a:rPr lang="en-US" altLang="en-US" baseline="30000" dirty="0"/>
-              <a:t>th</a:t>
-            </a:r>
-            <a:r>
-              <a:rPr lang="en-US" altLang="en-US" dirty="0"/>
-              <a:t> edition</a:t>
-            </a:r>
-          </a:p>
-          <a:p>
-            <a:pPr marL="228600" lvl="1">
-              <a:spcBef>
-                <a:spcPts val="1000"/>
-              </a:spcBef>
-              <a:defRPr/>
-            </a:pPr>
-            <a:endParaRPr lang="en-US" altLang="en-US" sz="2400" dirty="0"/>
           </a:p>
           <a:p>
             <a:pPr marL="228600" lvl="1">

</xml_diff>

<commit_message>
Added video on virtualization / containers
</commit_message>
<xml_diff>
--- a/slides/virtualization.pptx
+++ b/slides/virtualization.pptx
@@ -9762,7 +9762,7 @@
           <a:p>
             <a:fld id="{F5CA1724-FE87-D744-AEFA-DF7E2B83349C}" type="datetimeFigureOut">
               <a:rPr lang="en-SE" smtClean="0"/>
-              <a:t>7/14/26</a:t>
+              <a:t>8/18/26</a:t>
             </a:fld>
             <a:endParaRPr lang="en-SE"/>
           </a:p>
@@ -10547,29 +10547,6 @@
           <a:bodyPr/>
           <a:lstStyle/>
           <a:p>
-            <a:pPr marL="0" marR="0" lvl="0" indent="0" algn="l" defTabSz="914400" rtl="0" eaLnBrk="1" fontAlgn="auto" latinLnBrk="0" hangingPunct="1">
-              <a:lnSpc>
-                <a:spcPct val="100000"/>
-              </a:lnSpc>
-              <a:spcBef>
-                <a:spcPts val="0"/>
-              </a:spcBef>
-              <a:spcAft>
-                <a:spcPts val="0"/>
-              </a:spcAft>
-              <a:buClrTx/>
-              <a:buSzTx/>
-              <a:buFontTx/>
-              <a:buNone/>
-              <a:tabLst/>
-              <a:defRPr/>
-            </a:pPr>
-            <a:r>
-              <a:rPr lang="en-US" dirty="0"/>
-              <a:t>Containers became widely popular around 2013–2015, following Docker’s launch in 2013 and Kubernetes’ introduction in 2014. We can say that if a VM virtualizes hardware and runs a complete guest OS, then a container isolates one or more processes while sharing the host OS kernel. These processes are isolated from other processes, but their performance can still be affected by other workloads, as with VMs. The key difference is that containers also share the same kernel.</a:t>
-            </a:r>
-          </a:p>
-          <a:p>
             <a:endParaRPr lang="en-US" dirty="0"/>
           </a:p>
         </p:txBody>
@@ -10591,7 +10568,7 @@
           <a:p>
             <a:fld id="{C55E3DE0-5E9E-8947-9DAA-E91C371FD659}" type="slidenum">
               <a:rPr lang="en-SE" smtClean="0"/>
-              <a:t>37</a:t>
+              <a:t>36</a:t>
             </a:fld>
             <a:endParaRPr lang="en-SE"/>
           </a:p>
@@ -10600,7 +10577,7 @@
     </p:spTree>
     <p:extLst>
       <p:ext uri="{BB962C8B-B14F-4D97-AF65-F5344CB8AC3E}">
-        <p14:creationId xmlns:p14="http://schemas.microsoft.com/office/powerpoint/2010/main" val="3695974222"/>
+        <p14:creationId xmlns:p14="http://schemas.microsoft.com/office/powerpoint/2010/main" val="1799306669"/>
       </p:ext>
     </p:extLst>
   </p:cSld>
@@ -10673,7 +10650,7 @@
             </a:pPr>
             <a:r>
               <a:rPr lang="en-US" dirty="0"/>
-              <a:t>To isolate a set of processes, we must isolate resources and system views such as the filesystem, process IDs, user IDs, network interfaces, and IPC endpoints. For example, processes in different containers can have the same process ID. We may also define limits, quotas, or priorities for memory, CPU, and I/O. All in all, namespaces isolate what processes can see, while cgroups control or account for the resources they use.</a:t>
+              <a:t>Containers became widely popular around 2013–2015, following Docker’s launch in 2013 and Kubernetes’ introduction in 2014. We can say that if a VM virtualizes hardware and runs a complete guest OS, then a container isolates one or more processes while sharing the host OS kernel. These processes are isolated from other processes, but their performance can still be affected by other workloads, as with VMs. The key difference is that containers also share the same kernel.</a:t>
             </a:r>
           </a:p>
           <a:p>
@@ -10698,7 +10675,7 @@
           <a:p>
             <a:fld id="{C55E3DE0-5E9E-8947-9DAA-E91C371FD659}" type="slidenum">
               <a:rPr lang="en-SE" smtClean="0"/>
-              <a:t>38</a:t>
+              <a:t>37</a:t>
             </a:fld>
             <a:endParaRPr lang="en-SE"/>
           </a:p>
@@ -10707,7 +10684,7 @@
     </p:spTree>
     <p:extLst>
       <p:ext uri="{BB962C8B-B14F-4D97-AF65-F5344CB8AC3E}">
-        <p14:creationId xmlns:p14="http://schemas.microsoft.com/office/powerpoint/2010/main" val="831354887"/>
+        <p14:creationId xmlns:p14="http://schemas.microsoft.com/office/powerpoint/2010/main" val="3695974222"/>
       </p:ext>
     </p:extLst>
   </p:cSld>
@@ -10780,27 +10757,10 @@
             </a:pPr>
             <a:r>
               <a:rPr lang="en-US" dirty="0"/>
-              <a:t>Some of these features are handled through namespaces. A namespace is a kernel feature that limits or isolates what a process can see and access. A process belongs to one namespace of each type. New namespaces can be created when a process starts, and a process can also join an existing namespace. Memory, CPU, and I/O controls instead require the kernel to account for resource usage and enforce limits or priorities.</a:t>
-            </a:r>
-          </a:p>
-          <a:p>
-            <a:pPr marL="0" marR="0" lvl="0" indent="0" algn="l" defTabSz="914400" rtl="0" eaLnBrk="1" fontAlgn="auto" latinLnBrk="0" hangingPunct="1">
-              <a:lnSpc>
-                <a:spcPct val="100000"/>
-              </a:lnSpc>
-              <a:spcBef>
-                <a:spcPts val="0"/>
-              </a:spcBef>
-              <a:spcAft>
-                <a:spcPts val="0"/>
-              </a:spcAft>
-              <a:buClrTx/>
-              <a:buSzTx/>
-              <a:buFontTx/>
-              <a:buNone/>
-              <a:tabLst/>
-              <a:defRPr/>
-            </a:pPr>
+              <a:t>To isolate a set of processes, we must isolate resources and system views such as the filesystem, process IDs, user IDs, network interfaces, and IPC endpoints. That, as an example, allows for processes in different containers to have the same process ID. We may also define limits, quotas, or priorities for memory, CPU, and I/O. To do all this, we either use namespaces or cgroups. Namespaces isolate what processes can see, while cgroups control or account for the resources they use.</a:t>
+            </a:r>
+          </a:p>
+          <a:p>
             <a:endParaRPr lang="en-US" dirty="0"/>
           </a:p>
         </p:txBody>
@@ -10822,7 +10782,7 @@
           <a:p>
             <a:fld id="{C55E3DE0-5E9E-8947-9DAA-E91C371FD659}" type="slidenum">
               <a:rPr lang="en-SE" smtClean="0"/>
-              <a:t>39</a:t>
+              <a:t>38</a:t>
             </a:fld>
             <a:endParaRPr lang="en-SE"/>
           </a:p>
@@ -10831,7 +10791,7 @@
     </p:spTree>
     <p:extLst>
       <p:ext uri="{BB962C8B-B14F-4D97-AF65-F5344CB8AC3E}">
-        <p14:creationId xmlns:p14="http://schemas.microsoft.com/office/powerpoint/2010/main" val="615113770"/>
+        <p14:creationId xmlns:p14="http://schemas.microsoft.com/office/powerpoint/2010/main" val="831354887"/>
       </p:ext>
     </p:extLst>
   </p:cSld>
@@ -10885,14 +10845,89 @@
           <a:bodyPr/>
           <a:lstStyle/>
           <a:p>
+            <a:pPr marL="0" marR="0" lvl="0" indent="0" algn="l" defTabSz="914400" rtl="0" eaLnBrk="1" fontAlgn="auto" latinLnBrk="0" hangingPunct="1">
+              <a:lnSpc>
+                <a:spcPct val="100000"/>
+              </a:lnSpc>
+              <a:spcBef>
+                <a:spcPts val="0"/>
+              </a:spcBef>
+              <a:spcAft>
+                <a:spcPts val="0"/>
+              </a:spcAft>
+              <a:buClrTx/>
+              <a:buSzTx/>
+              <a:buFontTx/>
+              <a:buNone/>
+              <a:tabLst/>
+              <a:defRPr/>
+            </a:pPr>
             <a:r>
               <a:rPr lang="en-US" dirty="0"/>
-              <a:t>A mount namespace isolates the set of filesystem mounts visible to a process. Two processes in different mount namespaces may see different filesystems or different directory trees, even though they run on the same host. Container runtimes use mount namespaces together with other filesystem mechanisms to give each container its own root </a:t>
-            </a:r>
-            <a:r>
-              <a:rPr lang="en-US"/>
-              <a:t>filesystem.</a:t>
-            </a:r>
+              <a:t>More concretely, if we focus on namespaces, a namespace is a kernel feature that limits or isolates what a process can see and access. A process belongs to one namespace of each type. New namespaces can be created when a process starts. As an example, I might want to start a process and associate it with a new mount namespace, so that the process gets a restricted view of the filesystem, for example only a specific folder and its subfolders. In that case, I can create a new mount namespace and start the process in that namespace. A process can also join an existing namespace, of course, we do not need to create a new namespace for each new process. </a:t>
+            </a:r>
+          </a:p>
+          <a:p>
+            <a:pPr marL="0" marR="0" lvl="0" indent="0" algn="l" defTabSz="914400" rtl="0" eaLnBrk="1" fontAlgn="auto" latinLnBrk="0" hangingPunct="1">
+              <a:lnSpc>
+                <a:spcPct val="100000"/>
+              </a:lnSpc>
+              <a:spcBef>
+                <a:spcPts val="0"/>
+              </a:spcBef>
+              <a:spcAft>
+                <a:spcPts val="0"/>
+              </a:spcAft>
+              <a:buClrTx/>
+              <a:buSzTx/>
+              <a:buFontTx/>
+              <a:buNone/>
+              <a:tabLst/>
+              <a:defRPr/>
+            </a:pPr>
+            <a:endParaRPr lang="en-US" dirty="0"/>
+          </a:p>
+          <a:p>
+            <a:pPr marL="0" marR="0" lvl="0" indent="0" algn="l" defTabSz="914400" rtl="0" eaLnBrk="1" fontAlgn="auto" latinLnBrk="0" hangingPunct="1">
+              <a:lnSpc>
+                <a:spcPct val="100000"/>
+              </a:lnSpc>
+              <a:spcBef>
+                <a:spcPts val="0"/>
+              </a:spcBef>
+              <a:spcAft>
+                <a:spcPts val="0"/>
+              </a:spcAft>
+              <a:buClrTx/>
+              <a:buSzTx/>
+              <a:buFontTx/>
+              <a:buNone/>
+              <a:tabLst/>
+              <a:defRPr/>
+            </a:pPr>
+            <a:r>
+              <a:rPr lang="en-US" dirty="0"/>
+              <a:t>Nonetheless, as said before, for memory, CPU, and I/O a namespace is not enough because we need a mechanism for the kernel to account for resource usage and enforce limits or priorities.</a:t>
+            </a:r>
+          </a:p>
+          <a:p>
+            <a:pPr marL="0" marR="0" lvl="0" indent="0" algn="l" defTabSz="914400" rtl="0" eaLnBrk="1" fontAlgn="auto" latinLnBrk="0" hangingPunct="1">
+              <a:lnSpc>
+                <a:spcPct val="100000"/>
+              </a:lnSpc>
+              <a:spcBef>
+                <a:spcPts val="0"/>
+              </a:spcBef>
+              <a:spcAft>
+                <a:spcPts val="0"/>
+              </a:spcAft>
+              <a:buClrTx/>
+              <a:buSzTx/>
+              <a:buFontTx/>
+              <a:buNone/>
+              <a:tabLst/>
+              <a:defRPr/>
+            </a:pPr>
             <a:endParaRPr lang="en-US" dirty="0"/>
           </a:p>
         </p:txBody>
@@ -10914,7 +10949,7 @@
           <a:p>
             <a:fld id="{C55E3DE0-5E9E-8947-9DAA-E91C371FD659}" type="slidenum">
               <a:rPr lang="en-SE" smtClean="0"/>
-              <a:t>40</a:t>
+              <a:t>39</a:t>
             </a:fld>
             <a:endParaRPr lang="en-SE"/>
           </a:p>
@@ -10923,7 +10958,7 @@
     </p:spTree>
     <p:extLst>
       <p:ext uri="{BB962C8B-B14F-4D97-AF65-F5344CB8AC3E}">
-        <p14:creationId xmlns:p14="http://schemas.microsoft.com/office/powerpoint/2010/main" val="587956505"/>
+        <p14:creationId xmlns:p14="http://schemas.microsoft.com/office/powerpoint/2010/main" val="615113770"/>
       </p:ext>
     </p:extLst>
   </p:cSld>
@@ -10961,6 +10996,93 @@
           </p:nvPr>
         </p:nvSpPr>
         <p:spPr/>
+      </p:sp>
+      <p:sp>
+        <p:nvSpPr>
+          <p:cNvPr id="3" name="Notes Placeholder 2"/>
+          <p:cNvSpPr>
+            <a:spLocks noGrp="1"/>
+          </p:cNvSpPr>
+          <p:nvPr>
+            <p:ph type="body" idx="1"/>
+          </p:nvPr>
+        </p:nvSpPr>
+        <p:spPr/>
+        <p:txBody>
+          <a:bodyPr/>
+          <a:lstStyle/>
+          <a:p>
+            <a:r>
+              <a:rPr lang="en-US" dirty="0"/>
+              <a:t>Going back to the file system example, a mount namespace isolates the set of filesystem mounts visible to a process. Two processes in different mount namespaces may see different filesystems or different directory trees, even though they run on the same host. Container runtimes use mount namespaces together with other filesystem mechanisms to give each container its own root filesystem.</a:t>
+            </a:r>
+          </a:p>
+        </p:txBody>
+      </p:sp>
+      <p:sp>
+        <p:nvSpPr>
+          <p:cNvPr id="4" name="Slide Number Placeholder 3"/>
+          <p:cNvSpPr>
+            <a:spLocks noGrp="1"/>
+          </p:cNvSpPr>
+          <p:nvPr>
+            <p:ph type="sldNum" sz="quarter" idx="5"/>
+          </p:nvPr>
+        </p:nvSpPr>
+        <p:spPr/>
+        <p:txBody>
+          <a:bodyPr/>
+          <a:lstStyle/>
+          <a:p>
+            <a:fld id="{C55E3DE0-5E9E-8947-9DAA-E91C371FD659}" type="slidenum">
+              <a:rPr lang="en-SE" smtClean="0"/>
+              <a:t>40</a:t>
+            </a:fld>
+            <a:endParaRPr lang="en-SE"/>
+          </a:p>
+        </p:txBody>
+      </p:sp>
+    </p:spTree>
+    <p:extLst>
+      <p:ext uri="{BB962C8B-B14F-4D97-AF65-F5344CB8AC3E}">
+        <p14:creationId xmlns:p14="http://schemas.microsoft.com/office/powerpoint/2010/main" val="587956505"/>
+      </p:ext>
+    </p:extLst>
+  </p:cSld>
+  <p:clrMapOvr>
+    <a:masterClrMapping/>
+  </p:clrMapOvr>
+</p:notes>
+</file>
+
+<file path=ppt/notesSlides/notesSlide17.xml><?xml version="1.0" encoding="utf-8"?>
+<p:notes xmlns:a="http://schemas.openxmlformats.org/drawingml/2006/main" xmlns:r="http://schemas.openxmlformats.org/officeDocument/2006/relationships" xmlns:p="http://schemas.openxmlformats.org/presentationml/2006/main">
+  <p:cSld>
+    <p:spTree>
+      <p:nvGrpSpPr>
+        <p:cNvPr id="1" name=""/>
+        <p:cNvGrpSpPr/>
+        <p:nvPr/>
+      </p:nvGrpSpPr>
+      <p:grpSpPr>
+        <a:xfrm>
+          <a:off x="0" y="0"/>
+          <a:ext cx="0" cy="0"/>
+          <a:chOff x="0" y="0"/>
+          <a:chExt cx="0" cy="0"/>
+        </a:xfrm>
+      </p:grpSpPr>
+      <p:sp>
+        <p:nvSpPr>
+          <p:cNvPr id="2" name="Slide Image Placeholder 1"/>
+          <p:cNvSpPr>
+            <a:spLocks noGrp="1" noRot="1" noChangeAspect="1"/>
+          </p:cNvSpPr>
+          <p:nvPr>
+            <p:ph type="sldImg"/>
+          </p:nvPr>
+        </p:nvSpPr>
+        <p:spPr/>
         <p:txBody>
           <a:bodyPr/>
           <a:lstStyle/>
@@ -10986,7 +11108,7 @@
           <a:p>
             <a:r>
               <a:rPr lang="en-US" dirty="0"/>
-              <a:t>For resources that require monitoring, the kernel provides controllers for resource types such as CPU, memory, and I/O. For each resource, cgroups are organized in a tree and specify restrictions. A process can belong to one cgroup for each resource.</a:t>
+              <a:t>If we focus now on resources that require monitoring, what we have is that the kernel provides controllers for resource types such as CPU, memory, and I/O. For each resource, cgroups are organized in a tree and specify restrictions. A process can belong to one cgroup for each resource.</a:t>
             </a:r>
           </a:p>
           <a:p>
@@ -10995,7 +11117,7 @@
           <a:p>
             <a:r>
               <a:rPr lang="en-US" dirty="0"/>
-              <a:t>For example, we could have a CPU controller with a cgroup representing a 50% CPU limit—using percentages only as a simplification—and a memory controller with a cgroup limiting usage to 2 GB. To limit processes A and B together to 50% of the CPU, we place both in cgroup c1. To also limit B to 2 GB of memory, we place B in memory cgroup m1.</a:t>
+              <a:t>For example, we could have a CPU controller with a cgroup called c1 representing a 50% CPU limit—I am using percentages here only as a simplification—and a memory controller with a cgroup called m1 limiting usage to 2 GB. To limit processes A and B together to 50% of the CPU, we place both A and B in cgroup c1. To also limit process B to 2 GB of memory, we place B in memory cgroup m1.</a:t>
             </a:r>
           </a:p>
           <a:p>
@@ -11039,7 +11161,7 @@
 </p:notes>
 </file>
 
-<file path=ppt/notesSlides/notesSlide17.xml><?xml version="1.0" encoding="utf-8"?>
+<file path=ppt/notesSlides/notesSlide18.xml><?xml version="1.0" encoding="utf-8"?>
 <p:notes xmlns:a="http://schemas.openxmlformats.org/drawingml/2006/main" xmlns:r="http://schemas.openxmlformats.org/officeDocument/2006/relationships" xmlns:p="http://schemas.openxmlformats.org/presentationml/2006/main">
   <p:cSld>
     <p:spTree>
@@ -11137,7 +11259,7 @@
           <a:p>
             <a:r>
               <a:rPr lang="en-US" dirty="0"/>
-              <a:t>Some controllers affect related aspects of execution. The CPU controller manages CPU time, while the </a:t>
+              <a:t>Note that some controllers affect aspects of execution that are related. For instance, the CPU controller manages CPU time, while the </a:t>
             </a:r>
             <a:r>
               <a:rPr lang="en-US" dirty="0" err="1"/>
@@ -11145,7 +11267,7 @@
             </a:r>
             <a:r>
               <a:rPr lang="en-US" dirty="0"/>
-              <a:t> controller determines which CPUs a process may use. On a four-core system, restricting A and B to two cores prevents them from using more than two cores simultaneously.</a:t>
+              <a:t> controller determines which CPUs a process may use. On a four-core system, restricting A and B to two cores prevents them from using more than two cores simultaneously, so in a sense, that also limits A and B to maximum 50% of the CPU.</a:t>
             </a:r>
           </a:p>
           <a:p>
@@ -11255,7 +11377,7 @@
 </p:notes>
 </file>
 
-<file path=ppt/notesSlides/notesSlide18.xml><?xml version="1.0" encoding="utf-8"?>
+<file path=ppt/notesSlides/notesSlide19.xml><?xml version="1.0" encoding="utf-8"?>
 <p:notes xmlns:a="http://schemas.openxmlformats.org/drawingml/2006/main" xmlns:r="http://schemas.openxmlformats.org/officeDocument/2006/relationships" xmlns:p="http://schemas.openxmlformats.org/presentationml/2006/main">
   <p:cSld>
     <p:spTree>
@@ -11326,7 +11448,7 @@
           <a:p>
             <a:r>
               <a:rPr lang="en-US" dirty="0"/>
-              <a:t>Different restrictions may conflict. For example, a process may belong to a </a:t>
+              <a:t>Note also that different restrictions may conflict. For example, a process may belong to a </a:t>
             </a:r>
             <a:r>
               <a:rPr lang="en-US" dirty="0" err="1"/>
@@ -11334,7 +11456,7 @@
             </a:r>
             <a:r>
               <a:rPr lang="en-US" dirty="0"/>
-              <a:t> cgroup that permits only core 1, while one of its threads is pinned to core 2. The OS enforces the intersection of these restrictions. Since the thread has no eligible CPU, it cannot be scheduled until one restriction changes.</a:t>
+              <a:t> cgroup that permits only core 1, while one of its threads is pinned to core 2. The OS enforces the intersection of these restrictions. Since the thread has no eligible CPU, it cannot be scheduled until one of the restrictions changes.</a:t>
             </a:r>
           </a:p>
         </p:txBody>
@@ -11441,7 +11563,99 @@
 </p:notes>
 </file>
 
-<file path=ppt/notesSlides/notesSlide19.xml><?xml version="1.0" encoding="utf-8"?>
+<file path=ppt/notesSlides/notesSlide2.xml><?xml version="1.0" encoding="utf-8"?>
+<p:notes xmlns:a="http://schemas.openxmlformats.org/drawingml/2006/main" xmlns:r="http://schemas.openxmlformats.org/officeDocument/2006/relationships" xmlns:p="http://schemas.openxmlformats.org/presentationml/2006/main">
+  <p:cSld>
+    <p:spTree>
+      <p:nvGrpSpPr>
+        <p:cNvPr id="1" name=""/>
+        <p:cNvGrpSpPr/>
+        <p:nvPr/>
+      </p:nvGrpSpPr>
+      <p:grpSpPr>
+        <a:xfrm>
+          <a:off x="0" y="0"/>
+          <a:ext cx="0" cy="0"/>
+          <a:chOff x="0" y="0"/>
+          <a:chExt cx="0" cy="0"/>
+        </a:xfrm>
+      </p:grpSpPr>
+      <p:sp>
+        <p:nvSpPr>
+          <p:cNvPr id="2" name="Slide Image Placeholder 1"/>
+          <p:cNvSpPr>
+            <a:spLocks noGrp="1" noRot="1" noChangeAspect="1"/>
+          </p:cNvSpPr>
+          <p:nvPr>
+            <p:ph type="sldImg"/>
+          </p:nvPr>
+        </p:nvSpPr>
+        <p:spPr/>
+        <p:txBody>
+          <a:bodyPr/>
+          <a:lstStyle/>
+          <a:p>
+            <a:endParaRPr lang="en-US"/>
+          </a:p>
+        </p:txBody>
+      </p:sp>
+      <p:sp>
+        <p:nvSpPr>
+          <p:cNvPr id="3" name="Notes Placeholder 2"/>
+          <p:cNvSpPr>
+            <a:spLocks noGrp="1"/>
+          </p:cNvSpPr>
+          <p:nvPr>
+            <p:ph type="body" idx="1"/>
+          </p:nvPr>
+        </p:nvSpPr>
+        <p:spPr/>
+        <p:txBody>
+          <a:bodyPr/>
+          <a:lstStyle/>
+          <a:p>
+            <a:endParaRPr lang="en-US"/>
+          </a:p>
+        </p:txBody>
+      </p:sp>
+      <p:sp>
+        <p:nvSpPr>
+          <p:cNvPr id="4" name="Slide Number Placeholder 3"/>
+          <p:cNvSpPr>
+            <a:spLocks noGrp="1"/>
+          </p:cNvSpPr>
+          <p:nvPr>
+            <p:ph type="sldNum" sz="quarter" idx="10"/>
+          </p:nvPr>
+        </p:nvSpPr>
+        <p:spPr/>
+        <p:txBody>
+          <a:bodyPr/>
+          <a:lstStyle/>
+          <a:p>
+            <a:fld id="{CAE0ABF5-7690-4623-B971-046A51D617CD}" type="slidenum">
+              <a:rPr lang="en-US" altLang="en-US" smtClean="0"/>
+              <a:pPr/>
+              <a:t>2</a:t>
+            </a:fld>
+            <a:endParaRPr lang="en-US" altLang="en-US"/>
+          </a:p>
+        </p:txBody>
+      </p:sp>
+    </p:spTree>
+    <p:extLst>
+      <p:ext uri="{BB962C8B-B14F-4D97-AF65-F5344CB8AC3E}">
+        <p14:creationId xmlns:p14="http://schemas.microsoft.com/office/powerpoint/2010/main" val="704346850"/>
+      </p:ext>
+    </p:extLst>
+  </p:cSld>
+  <p:clrMapOvr>
+    <a:masterClrMapping/>
+  </p:clrMapOvr>
+</p:notes>
+</file>
+
+<file path=ppt/notesSlides/notesSlide20.xml><?xml version="1.0" encoding="utf-8"?>
 <p:notes xmlns:a="http://schemas.openxmlformats.org/drawingml/2006/main" xmlns:r="http://schemas.openxmlformats.org/officeDocument/2006/relationships" xmlns:p="http://schemas.openxmlformats.org/presentationml/2006/main">
   <p:cSld>
     <p:spTree>
@@ -11512,7 +11726,7 @@
           <a:p>
             <a:r>
               <a:rPr lang="en-US" dirty="0"/>
-              <a:t>Different controllers manage different resources. For example, the CPU controller manages CPU bandwidth or relative weight, </a:t>
+              <a:t>As we said, different controllers manage different resources. For example, the CPU controller manages CPU bandwidth or relative weight, </a:t>
             </a:r>
             <a:r>
               <a:rPr lang="en-US" dirty="0" err="1"/>
@@ -11528,37 +11742,7 @@
             </a:r>
             <a:r>
               <a:rPr lang="en-US" dirty="0"/>
-              <a:t> limits the number of processes or tasks. The devices controller manages device access. For disk I/O, </a:t>
-            </a:r>
-            <a:r>
-              <a:rPr lang="en-US" sz="1200" kern="1200" dirty="0" err="1">
-                <a:solidFill>
-                  <a:schemeClr val="tx1"/>
-                </a:solidFill>
-                <a:latin typeface="+mn-lt"/>
-                <a:ea typeface="+mn-ea"/>
-                <a:cs typeface="+mn-cs"/>
-              </a:rPr>
-              <a:t>blkio</a:t>
-            </a:r>
-            <a:r>
-              <a:rPr lang="en-US" dirty="0"/>
-              <a:t> is the cgroup v1 controller, while </a:t>
-            </a:r>
-            <a:r>
-              <a:rPr lang="en-US" sz="1200" kern="1200" dirty="0">
-                <a:solidFill>
-                  <a:schemeClr val="tx1"/>
-                </a:solidFill>
-                <a:latin typeface="+mn-lt"/>
-                <a:ea typeface="+mn-ea"/>
-                <a:cs typeface="+mn-cs"/>
-              </a:rPr>
-              <a:t>io</a:t>
-            </a:r>
-            <a:r>
-              <a:rPr lang="en-US" dirty="0"/>
-              <a:t> is the corresponding cgroup v2 controller.</a:t>
+              <a:t> limits the number of processes or tasks. The devices controller manages device access.</a:t>
             </a:r>
           </a:p>
         </p:txBody>
@@ -11665,99 +11849,7 @@
 </p:notes>
 </file>
 
-<file path=ppt/notesSlides/notesSlide2.xml><?xml version="1.0" encoding="utf-8"?>
-<p:notes xmlns:a="http://schemas.openxmlformats.org/drawingml/2006/main" xmlns:r="http://schemas.openxmlformats.org/officeDocument/2006/relationships" xmlns:p="http://schemas.openxmlformats.org/presentationml/2006/main">
-  <p:cSld>
-    <p:spTree>
-      <p:nvGrpSpPr>
-        <p:cNvPr id="1" name=""/>
-        <p:cNvGrpSpPr/>
-        <p:nvPr/>
-      </p:nvGrpSpPr>
-      <p:grpSpPr>
-        <a:xfrm>
-          <a:off x="0" y="0"/>
-          <a:ext cx="0" cy="0"/>
-          <a:chOff x="0" y="0"/>
-          <a:chExt cx="0" cy="0"/>
-        </a:xfrm>
-      </p:grpSpPr>
-      <p:sp>
-        <p:nvSpPr>
-          <p:cNvPr id="2" name="Slide Image Placeholder 1"/>
-          <p:cNvSpPr>
-            <a:spLocks noGrp="1" noRot="1" noChangeAspect="1"/>
-          </p:cNvSpPr>
-          <p:nvPr>
-            <p:ph type="sldImg"/>
-          </p:nvPr>
-        </p:nvSpPr>
-        <p:spPr/>
-        <p:txBody>
-          <a:bodyPr/>
-          <a:lstStyle/>
-          <a:p>
-            <a:endParaRPr lang="en-US"/>
-          </a:p>
-        </p:txBody>
-      </p:sp>
-      <p:sp>
-        <p:nvSpPr>
-          <p:cNvPr id="3" name="Notes Placeholder 2"/>
-          <p:cNvSpPr>
-            <a:spLocks noGrp="1"/>
-          </p:cNvSpPr>
-          <p:nvPr>
-            <p:ph type="body" idx="1"/>
-          </p:nvPr>
-        </p:nvSpPr>
-        <p:spPr/>
-        <p:txBody>
-          <a:bodyPr/>
-          <a:lstStyle/>
-          <a:p>
-            <a:endParaRPr lang="en-US"/>
-          </a:p>
-        </p:txBody>
-      </p:sp>
-      <p:sp>
-        <p:nvSpPr>
-          <p:cNvPr id="4" name="Slide Number Placeholder 3"/>
-          <p:cNvSpPr>
-            <a:spLocks noGrp="1"/>
-          </p:cNvSpPr>
-          <p:nvPr>
-            <p:ph type="sldNum" sz="quarter" idx="10"/>
-          </p:nvPr>
-        </p:nvSpPr>
-        <p:spPr/>
-        <p:txBody>
-          <a:bodyPr/>
-          <a:lstStyle/>
-          <a:p>
-            <a:fld id="{CAE0ABF5-7690-4623-B971-046A51D617CD}" type="slidenum">
-              <a:rPr lang="en-US" altLang="en-US" smtClean="0"/>
-              <a:pPr/>
-              <a:t>2</a:t>
-            </a:fld>
-            <a:endParaRPr lang="en-US" altLang="en-US"/>
-          </a:p>
-        </p:txBody>
-      </p:sp>
-    </p:spTree>
-    <p:extLst>
-      <p:ext uri="{BB962C8B-B14F-4D97-AF65-F5344CB8AC3E}">
-        <p14:creationId xmlns:p14="http://schemas.microsoft.com/office/powerpoint/2010/main" val="704346850"/>
-      </p:ext>
-    </p:extLst>
-  </p:cSld>
-  <p:clrMapOvr>
-    <a:masterClrMapping/>
-  </p:clrMapOvr>
-</p:notes>
-</file>
-
-<file path=ppt/notesSlides/notesSlide20.xml><?xml version="1.0" encoding="utf-8"?>
+<file path=ppt/notesSlides/notesSlide21.xml><?xml version="1.0" encoding="utf-8"?>
 <p:notes xmlns:a="http://schemas.openxmlformats.org/drawingml/2006/main" xmlns:r="http://schemas.openxmlformats.org/officeDocument/2006/relationships" xmlns:p="http://schemas.openxmlformats.org/presentationml/2006/main">
   <p:cSld>
     <p:spTree>
@@ -11812,7 +11904,7 @@
           <a:p>
             <a:r>
               <a:rPr lang="en-US" dirty="0"/>
-              <a:t>In cgroup v1, controllers can use separate hierarchies, so a process may belong to one cgroup for CPU control and another for memory control. This is flexible but can be difficult to manage.</a:t>
+              <a:t>In cgroup v1, controllers can use separate hierarchies, so a process may belong to one cgroup for CPU control and another for memory control.</a:t>
             </a:r>
           </a:p>
           <a:p>
@@ -11871,7 +11963,7 @@
 </p:notes>
 </file>
 
-<file path=ppt/notesSlides/notesSlide21.xml><?xml version="1.0" encoding="utf-8"?>
+<file path=ppt/notesSlides/notesSlide22.xml><?xml version="1.0" encoding="utf-8"?>
 <p:notes xmlns:a="http://schemas.openxmlformats.org/drawingml/2006/main" xmlns:r="http://schemas.openxmlformats.org/officeDocument/2006/relationships" xmlns:p="http://schemas.openxmlformats.org/presentationml/2006/main">
   <p:cSld>
     <p:spTree>
@@ -11996,7 +12088,7 @@
           <a:p>
             <a:r>
               <a:rPr lang="en-US" dirty="0"/>
-              <a:t>In this example, these three groups and G1 have equal shares. Under contention, G1 therefore receives approximately one quarter of the available CPU time. Shares matter only during contention: they define relative fairness, not fixed limits.</a:t>
+              <a:t>In this example, these three groups and G1 have equal shares. Note that shares matter only during contention, because they define relative fairness, not fixed limits. Under contention, G1 therefore receives approximately one quarter of the available CPU time.</a:t>
             </a:r>
           </a:p>
           <a:p>
@@ -12014,7 +12106,7 @@
           <a:p>
             <a:r>
               <a:rPr lang="en-US" dirty="0"/>
-              <a:t>A strict maximum instead can be for instance enforced with </a:t>
+              <a:t>If you want to enforce a strict max, you can do that instead with </a:t>
             </a:r>
             <a:r>
               <a:rPr lang="en-US" sz="1200" kern="1200" dirty="0" err="1">
@@ -12029,13 +12121,8 @@
             </a:r>
             <a:r>
               <a:rPr lang="en-US" dirty="0"/>
-              <a:t> in </a:t>
-            </a:r>
-            <a:r>
-              <a:rPr lang="en-US"/>
-              <a:t>cgroup v2.</a:t>
-            </a:r>
-            <a:endParaRPr lang="en-US" dirty="0"/>
+              <a:t> in cgroup v2.</a:t>
+            </a:r>
           </a:p>
           <a:p>
             <a:endParaRPr lang="en-US" dirty="0"/>
@@ -12144,7 +12231,7 @@
 </p:notes>
 </file>
 
-<file path=ppt/notesSlides/notesSlide22.xml><?xml version="1.0" encoding="utf-8"?>
+<file path=ppt/notesSlides/notesSlide23.xml><?xml version="1.0" encoding="utf-8"?>
 <p:notes xmlns:a="http://schemas.openxmlformats.org/drawingml/2006/main" xmlns:r="http://schemas.openxmlformats.org/officeDocument/2006/relationships" xmlns:p="http://schemas.openxmlformats.org/presentationml/2006/main">
   <p:cSld>
     <p:spTree>
@@ -12221,7 +12308,16 @@
           <a:p>
             <a:r>
               <a:rPr lang="en-US" dirty="0"/>
-              <a:t>Here, G2.1 is limited to 1 GB and G2.2 to 1.5 GB. Together, however, they cannot use more than the 2 GB limit of their parent, G2. A child cgroup is constrained by both its own limit and its ancestors’ limits.</a:t>
+              <a:t>Here, G2.1 is limited to 1 GB and G2.2 to 1.5 GB. Together, however, they cannot use more than the 2 GB limit of their parent, G2. </a:t>
+            </a:r>
+          </a:p>
+          <a:p>
+            <a:endParaRPr lang="en-US" dirty="0"/>
+          </a:p>
+          <a:p>
+            <a:r>
+              <a:rPr lang="en-US" dirty="0"/>
+              <a:t>A child cgroup is constrained by both its own limit and its ancestors’ limits.</a:t>
             </a:r>
           </a:p>
           <a:p>
@@ -12348,7 +12444,7 @@
 </p:notes>
 </file>
 
-<file path=ppt/notesSlides/notesSlide23.xml><?xml version="1.0" encoding="utf-8"?>
+<file path=ppt/notesSlides/notesSlide24.xml><?xml version="1.0" encoding="utf-8"?>
 <p:notes xmlns:a="http://schemas.openxmlformats.org/drawingml/2006/main" xmlns:r="http://schemas.openxmlformats.org/officeDocument/2006/relationships" xmlns:p="http://schemas.openxmlformats.org/presentationml/2006/main">
   <p:cSld>
     <p:spTree>
@@ -12416,6 +12512,15 @@
         <p:txBody>
           <a:bodyPr/>
           <a:lstStyle/>
+          <a:p>
+            <a:r>
+              <a:rPr lang="en-US" dirty="0"/>
+              <a:t>If you want, you can check the membership of each process.</a:t>
+            </a:r>
+          </a:p>
+          <a:p>
+            <a:endParaRPr lang="en-US" dirty="0"/>
+          </a:p>
           <a:p>
             <a:r>
               <a:rPr lang="en-US" dirty="0"/>
@@ -12526,7 +12631,7 @@
 </p:notes>
 </file>
 
-<file path=ppt/notesSlides/notesSlide24.xml><?xml version="1.0" encoding="utf-8"?>
+<file path=ppt/notesSlides/notesSlide25.xml><?xml version="1.0" encoding="utf-8"?>
 <p:notes xmlns:a="http://schemas.openxmlformats.org/drawingml/2006/main" xmlns:r="http://schemas.openxmlformats.org/officeDocument/2006/relationships" xmlns:p="http://schemas.openxmlformats.org/presentationml/2006/main">
   <p:cSld>
     <p:spTree>
@@ -12597,7 +12702,15 @@
           <a:p>
             <a:r>
               <a:rPr lang="en-US" dirty="0"/>
-              <a:t>This directory contains the cgroup v1 </a:t>
+              <a:t>If you want to check the cgroup user-slice for </a:t>
+            </a:r>
+            <a:r>
+              <a:rPr lang="en-US" dirty="0" err="1"/>
+              <a:t>blkio</a:t>
+            </a:r>
+            <a:r>
+              <a:rPr lang="en-US" dirty="0"/>
+              <a:t>, then this directory contains the cgroup v1 </a:t>
             </a:r>
             <a:r>
               <a:rPr lang="en-US" sz="1200" kern="1200" dirty="0" err="1">
@@ -12630,7 +12743,7 @@
               <a:t>. For example, reading </a:t>
             </a:r>
             <a:r>
-              <a:rPr lang="en-US" sz="1200" kern="1200" dirty="0" err="1">
+              <a:rPr lang="en-US" sz="1200" kern="1200" dirty="0">
                 <a:solidFill>
                   <a:schemeClr val="tx1"/>
                 </a:solidFill>
@@ -12638,11 +12751,11 @@
                 <a:ea typeface="+mn-ea"/>
                 <a:cs typeface="+mn-cs"/>
               </a:rPr>
-              <a:t>blkio.throttle.io_service_bytes</a:t>
+              <a:t>the highlighted file </a:t>
             </a:r>
             <a:r>
               <a:rPr lang="en-US" dirty="0"/>
-              <a:t> shows the accumulated bytes transferred by devices for this cgroup.</a:t>
+              <a:t>shows the accumulated bytes transferred by devices for this cgroup.</a:t>
             </a:r>
           </a:p>
         </p:txBody>

</xml_diff>